<commit_message>
fix(interpret): tight abstract-style interpretation, not a 500-word essay
Round 1 feedback was "too minimal (just correlations)"; the fix over-corrected
to a 5-section ~500-word discussion. Retune to an abstract: Answer / Why /
Trust / Next, under 180 words, lead with the answer, one top caveat (not all),
mechanisms in <=6 words. Bumped max_tokens (this model spends tokens on
reasoning, was truncating the last section). All four studies re-interpreted
(142-190 words each); deck regenerated.

Co-Authored-By: Claude Opus 4.8 <noreply@anthropic.com>
</commit_message>
<xml_diff>
--- a/docs/slides/story_20260704.pptx
+++ b/docs/slides/story_20260704.pptx
@@ -3396,7 +3396,7 @@
                   <a:srgbClr val="0F172A"/>
                 </a:solidFill>
               </a:rPr>
-              <a:t>Key findings</a:t>
+              <a:t>Answer**</a:t>
             </a:r>
           </a:p>
           <a:p>
@@ -3419,7 +3419,7 @@
                   <a:srgbClr val="0F172A"/>
                 </a:solidFill>
               </a:rPr>
-              <a:t>1. Under wet forcing (1373 mm/yr), the profile is drainage-dominated: recharge fraction 0.81–0.87, runoff only 0.13–0.19 (col_02–col_08).</a:t>
+              <a:t>Under wetter forcing (1373 mm/yr) the representative Naches profile routes ~81–87% of water to sub-surface drainage/recharge and only ~13–19% to surface runoff (col_02–08), but this partitioning is soil- and forcing-controlled, not elevation-driven. Observational validation largely fails (streamflow NSE=−1.13, KGE=−0.57), so the split is a process result, not a validated basin flux.</a:t>
             </a:r>
           </a:p>
           <a:p>
@@ -3442,7 +3442,7 @@
                   <a:srgbClr val="0F172A"/>
                 </a:solidFill>
               </a:rPr>
-              <a:t>2. The dry column (col_01, 793 mm/yr) collapses to runoff-only: recharge ≈ 0 (−0.03 mm/yr), runoff_fraction 1.0006 — a threshold/nonlinear water-availability effect, not a gradient.</a:t>
+              <a:t>Why**</a:t>
             </a:r>
           </a:p>
           <a:p>
@@ -3465,7 +3465,7 @@
                   <a:srgbClr val="0F172A"/>
                 </a:solidFill>
               </a:rPr>
-              <a:t>3. Recharge tracks precip (r=0.908) far more than elevation (r=0.598, fit r²=0.36) — forcing is quantized to 2 values and NOT elevation-resolved, so no true elevation mechanism exists.</a:t>
+              <a:t>Precip 793→1373 mm/yr -&gt; recharge flips −0.03 to 346–648 mm/yr (r=0.908) -&gt; deeper profile wetting.</a:t>
             </a:r>
           </a:p>
           <a:p>
@@ -3488,7 +3488,7 @@
                   <a:srgbClr val="0F172A"/>
                 </a:solidFill>
               </a:rPr>
-              <a:t>4. With precip held at 1373, recharge vs clay_max r=−0.906 is the dominant soil control; ksat_min only r=0.492.</a:t>
+              <a:t>Higher clay_max -&gt; lower recharge (r=−0.906) -&gt; low-Ksat layer impedes vertical drainage.</a:t>
             </a:r>
           </a:p>
           <a:p>
@@ -3511,7 +3511,7 @@
                   <a:srgbClr val="0F172A"/>
                 </a:solidFill>
               </a:rPr>
-              <a:t>5. Modeled water yield 557.8 mm/yr is ~2.5× below observed specific discharge 1426.8 mm/yr; daily NSE=−1.13, KGE=−0.57 (r=0.05).</a:t>
+              <a:t>Dry column (col_01, 793 mm) -&gt; recharge_fraction −0.0006, runoff ~1.0 -&gt; ET consumes nearly all infiltration.</a:t>
             </a:r>
           </a:p>
           <a:p>
@@ -3534,7 +3534,7 @@
                   <a:srgbClr val="0F172A"/>
                 </a:solidFill>
               </a:rPr>
-              <a:t>Water-balance story</a:t>
+              <a:t>Elevation fit weak (r²=0.36, uniform forcing) -&gt; no resolvable snow/orographic control.</a:t>
             </a:r>
           </a:p>
           <a:p>
@@ -3557,7 +3557,7 @@
                   <a:srgbClr val="0F172A"/>
                 </a:solidFill>
               </a:rPr>
-              <a:t>Two regimes emerge. **Wet columns (1373 mm):** e.g. col_05 sends 648 mm (0.87) to sub-surface drainage, 93.5 mm (0.13) to overland flow, leaving ~631 mm to ET+storage — a deep-percolation regime where the coarse, low-clay profiles (clay_max 7.5–14%) transmit almost all infiltrated water downward. **Dry column (col_01, 793 mm):** recharge is essentially zero and all 53.4 mm of yield is QOVER, with ~740 mm going to ET/storage. Mechanistically, col_01's silty restricting layer (clay_max 32.5%, ksat_min 3.0 µm/s) caps vertical conductivity so that under limited supply ET plus the low-ksat barrier starve recharge, forcing the small residual flux to the surface. Across the 7 wet columns the clay→recharge anticorrelation (−0.906) confirms the restricting layer partitions infiltration vs. drainage. TWS seasonal ranges are large (485–1043 mm) and WTD sits at ~8.1–8.8 m in all columns — a shallow/perched, un-spun-up table, so closure cannot be verified term-by-term from these outputs (no explicit residual given; the large TWS swing signals unequilibrated storage).</a:t>
+              <a:t>Trust**</a:t>
             </a:r>
           </a:p>
           <a:p>
@@ -3580,7 +3580,7 @@
                   <a:srgbClr val="0F172A"/>
                 </a:solidFill>
               </a:rPr>
-              <a:t>What the validation says</a:t>
+              <a:t>Wells (obs 15.2 m vs model 8.3 m ZWT) and streamflow (557 vs 1427 mm/yr; NSE=−1.13) contradict absolute fluxes; top caveat — single unrouted, un-spun-up columns with elevation-uniform forcing cannot reproduce integrated gauge flow.</a:t>
             </a:r>
           </a:p>
           <a:p>
@@ -3603,7 +3603,7 @@
                   <a:srgbClr val="0F172A"/>
                 </a:solidFill>
               </a:rPr>
-              <a:t>All quantitative validation is diagnostic of missing physics, not model skill. Yield is under-predicted 2.5× and the hydrograph is anti-skillful (NSE&lt;0, r=0.05, α=0.18 → far too little variability, β=0.06 → near-zero bias in mean but wrong timing). This is exactly the signature of **no routing + no snow + single-gauge headwater mismatch**: unrouted column-mean QOVER+QDRAI cannot reproduce snowmelt-driven timing. WTD (8.31 m model vs 1.18 Fan vs 15.23 obs wells) confirms decoupling of the column from regional groundwater without coupling/spin-up. SWE is context-only (this run predates H2OSNO output).</a:t>
+              <a:t>Next**</a:t>
             </a:r>
           </a:p>
           <a:p>
@@ -3626,7 +3626,7 @@
                   <a:srgbClr val="0F172A"/>
                 </a:solidFill>
               </a:rPr>
-              <a:t>Caveats</a:t>
+              <a:t>Add runoff routing + area-weighting to test the modeled 13–19% runoff share against gauge yield.</a:t>
             </a:r>
           </a:p>
           <a:p>
@@ -3649,99 +3649,7 @@
                   <a:srgbClr val="0F172A"/>
                 </a:solidFill>
               </a:rPr>
-              <a:t>Forcing is uniform coarse reanalysis (only 2 precip values, no lapse/orographic), so the brief's primary elevation/snow control is absent — treat any "elevation slope" as spurious. 1-yr, no spin-up ⇒ deep storage/WTD unreliable. Single-column, no routing ⇒ no integrated streamflow. SSURGO gave one point; the soil axis is inferred from 7 profiles with only col_01 as the high-clay leverage point — the −0.906 correlation hinges heavily on that single dry/clay-rich replicate (N=1 at the clay extreme, and it is confounded with lower precip).</a:t>
-            </a:r>
-          </a:p>
-          <a:p>
-            <a:pPr>
-              <a:spcAft>
-                <a:spcPts val="600"/>
-              </a:spcAft>
-            </a:pPr>
-            <a:r>
-              <a:rPr b="1" sz="1400">
-                <a:solidFill>
-                  <a:srgbClr val="2C7FB8"/>
-                </a:solidFill>
-              </a:rPr>
-              <a:t>finding:  </a:t>
-            </a:r>
-            <a:r>
-              <a:rPr sz="1400">
-                <a:solidFill>
-                  <a:srgbClr val="0F172A"/>
-                </a:solidFill>
-              </a:rPr>
-              <a:t>Recommended next experiments</a:t>
-            </a:r>
-          </a:p>
-          <a:p>
-            <a:pPr>
-              <a:spcAft>
-                <a:spcPts val="600"/>
-              </a:spcAft>
-            </a:pPr>
-            <a:r>
-              <a:rPr b="1" sz="1400">
-                <a:solidFill>
-                  <a:srgbClr val="2C7FB8"/>
-                </a:solidFill>
-              </a:rPr>
-              <a:t>finding:  </a:t>
-            </a:r>
-            <a:r>
-              <a:rPr sz="1400">
-                <a:solidFill>
-                  <a:srgbClr val="0F172A"/>
-                </a:solidFill>
-              </a:rPr>
-              <a:t>1. **Elevation-downscaled forcing** (lapse rate + orographic precip) to separate the confounded precip/elevation signal and enable the intended snow-regime test.</a:t>
-            </a:r>
-          </a:p>
-          <a:p>
-            <a:pPr>
-              <a:spcAft>
-                <a:spcPts val="600"/>
-              </a:spcAft>
-            </a:pPr>
-            <a:r>
-              <a:rPr b="1" sz="1400">
-                <a:solidFill>
-                  <a:srgbClr val="2C7FB8"/>
-                </a:solidFill>
-              </a:rPr>
-              <a:t>finding:  </a:t>
-            </a:r>
-            <a:r>
-              <a:rPr sz="1400">
-                <a:solidFill>
-                  <a:srgbClr val="0F172A"/>
-                </a:solidFill>
-              </a:rPr>
-              <a:t>2. **Runoff routing + area-weighted aggregation** to gage 12488500, re-scoring NSE/KGE — directly addresses the −1.13 NSE.</a:t>
-            </a:r>
-          </a:p>
-          <a:p>
-            <a:pPr>
-              <a:spcAft>
-                <a:spcPts val="600"/>
-              </a:spcAft>
-            </a:pPr>
-            <a:r>
-              <a:rPr b="1" sz="1400">
-                <a:solidFill>
-                  <a:srgbClr val="2C7FB8"/>
-                </a:solidFill>
-              </a:rPr>
-              <a:t>finding:  </a:t>
-            </a:r>
-            <a:r>
-              <a:rPr sz="1400">
-                <a:solidFill>
-                  <a:srgbClr val="0F172A"/>
-                </a:solidFill>
-              </a:rPr>
-              <a:t>3. **Multi-year spin-up + groundwater coupling** to equilibrate WTD before comparing to Fan/well data (8.31 vs 15.23 m).</a:t>
+              <a:t>Apply elevation-downscaled forcing + SWE output to resolve the missing snow-regime partitioning control.</a:t>
             </a:r>
           </a:p>
         </p:txBody>
@@ -4839,7 +4747,7 @@
                   <a:srgbClr val="0F172A"/>
                 </a:solidFill>
               </a:rPr>
-              <a:t>Key findings</a:t>
+              <a:t>Answer**</a:t>
             </a:r>
           </a:p>
           <a:p>
@@ -4862,7 +4770,7 @@
                   <a:srgbClr val="0F172A"/>
                 </a:solidFill>
               </a:rPr>
-              <a:t>1. Under uniform 530 mm/yr forcing, ET dominates the budget: for all silt-loam/loam columns runoff is only ~26–30 mm/yr and recharge ≈0, so ~500 mm/yr (~94%) leaves as ET+storage.</a:t>
+              <a:t>Partitioning is runoff- and ET-dominated: with uniform 530 mm/yr precip, 7 of 8 columns route essentially all drainage to surface runoff (~26–30 mm/yr) with near-zero/negative recharge, leaving ET as the ~500 mm/yr residual. Deep recharge appears only in the sandy-loam column (col_02: 94.8 mm/yr, 71% of P), so recharge is soil-controlled, not elevation-controlled.</a:t>
             </a:r>
           </a:p>
           <a:p>
@@ -4885,7 +4793,7 @@
                   <a:srgbClr val="0F172A"/>
                 </a:solidFill>
               </a:rPr>
-              <a:t>2. Partitioning is entirely soil-driven, not elevation-driven: precip is quantized to one value (530), elevation fit is weak (r²=0.20, r=−0.44), so no climate gradient is testable.</a:t>
+              <a:t>Why**</a:t>
             </a:r>
           </a:p>
           <a:p>
@@ -4908,7 +4816,7 @@
                   <a:srgbClr val="0F172A"/>
                 </a:solidFill>
               </a:rPr>
-              <a:t>3. The single sandy-loam column (col_02, Ksat 92 µm/s, clay 3.5%) is the sole recharge outlier: 94.8 mm/yr recharge (71% of P), 38.5 runoff (29%) — a one-column leverage point.</a:t>
+              <a:t>High Ksat -&gt; recharge (r=0.993); col_02 (Ksat 92 µm/s) yields 94.8 mm/yr — coarse soil permits drainage.</a:t>
             </a:r>
           </a:p>
           <a:p>
@@ -4931,7 +4839,7 @@
                   <a:srgbClr val="0F172A"/>
                 </a:solidFill>
               </a:rPr>
-              <a:t>4. Recharge tracks Ksat almost perfectly (r=0.993) and is impeded by clay (recharge–clay r=−0.55, runoff–clay r=−0.57).</a:t>
+              <a:t>High clay -&gt; suppressed recharge (r=−0.545); silt/loam columns (Ksat 0.9–9) sit at ~0 mm/yr — fine pores impede percolation.</a:t>
             </a:r>
           </a:p>
           <a:p>
@@ -4954,7 +4862,7 @@
                   <a:srgbClr val="0F172A"/>
                 </a:solidFill>
               </a:rPr>
-              <a:t>5. Silt-loam/loam columns (Ksat 0.9–9 µm/s) show slightly negative recharge (−0.004 to −0.69 mm/yr): net upward flux, i.e. no deep drainage at all.</a:t>
+              <a:t>Uniform forcing (1 precip bin, 530 mm/yr) -&gt; weak elevation fit (r²=0.20) — apparent gradient is really soil.</a:t>
             </a:r>
           </a:p>
           <a:p>
@@ -4977,7 +4885,7 @@
                   <a:srgbClr val="0F172A"/>
                 </a:solidFill>
               </a:rPr>
-              <a:t>6. Modeled water yield 40.7 mm/yr is 4–17× below the four gauges (151.6, 714.9, 404.3, 158.1 mm/yr); daily hydrograph NSE=−1.46, KGE=−0.15.</a:t>
+              <a:t>Low runoff + ~0 recharge -&gt; ET dominates (~500 mm/yr residual) — semi-arid evaporative demand.</a:t>
             </a:r>
           </a:p>
           <a:p>
@@ -5000,7 +4908,7 @@
                   <a:srgbClr val="0F172A"/>
                 </a:solidFill>
               </a:rPr>
-              <a:t>Water-balance story</a:t>
+              <a:t>Trust**</a:t>
             </a:r>
           </a:p>
           <a:p>
@@ -5023,7 +4931,7 @@
                   <a:srgbClr val="0F172A"/>
                 </a:solidFill>
               </a:rPr>
-              <a:t>With P≈530 mm/yr held uniform, the columns partition into two regimes. **Low-Ksat regime (7 of 8, Ksat ≤9 µm/s):** infiltration cannot outrun evaporative demand, so ET consumes ~500 mm/yr, surface runoff (QOVER) is ~26–30 mm/yr, and QDRAI is effectively zero or slightly negative — the deep node draws water upward, meaning no recharge to the water table. **High-Ksat regime (col_02, sandy loam):** rapid infiltration routes 94.8 mm/yr to deep drainage and cuts ET's share, flipping the recharge:runoff ratio to 2.46. TWS seasonal ranges (238–291 mm) are large relative to fluxes, so the 1-yr, no-spin-up run has substantial transient storage change; closure "residual" is therefore not cleanly attributable and should not be over-read. The mechanism is textbook: clay lowers Ksat, throttling vertical percolation and forcing water to either evaporate or run off — which is exactly what col_04 (clay_max 45%, Ksat 0.91) shows (recharge ≈ −0.004).</a:t>
+              <a:t>Observations contradict magnitude: yield 40.7 vs gauged 152–715 mm/yr, hydrograph NSE=−1.46, WTD 8.8 vs 63.9 m. Top caveat: single-column, no routing/spin-up/elevation-downscaled forcing — headwater snow and lateral flow are missing.</a:t>
             </a:r>
           </a:p>
           <a:p>
@@ -5046,7 +4954,7 @@
                   <a:srgbClr val="0F172A"/>
                 </a:solidFill>
               </a:rPr>
-              <a:t>What the validation says</a:t>
+              <a:t>Next**</a:t>
             </a:r>
           </a:p>
           <a:p>
@@ -5069,7 +4977,7 @@
                   <a:srgbClr val="0F172A"/>
                 </a:solidFill>
               </a:rPr>
-              <a:t>Every quantitative target fails as expected for single-column physics: yield underpredicts gauges 4–17×, NSE/KGE are negative (r=0.235, α=0.70, β=0.19 — the model has both timing and volume errors), and modeled shallow ZWT (8.8 m) vs Fan (43.7 m) vs wells (63.9 m) confirms the column table is a transient perched feature, not the regional aquifer. SWE is context-only (obs peak 843 mm vs 530 mm forcing). None of this indicts the partitioning physics — it quantifies the cost of missing routing, snow, spin-up, and downscaled forcing.</a:t>
+              <a:t>Add elevation-downscaled forcing + SWE output to capture montane snowmelt runoff (missing yield).</a:t>
             </a:r>
           </a:p>
           <a:p>
@@ -5092,99 +5000,7 @@
                   <a:srgbClr val="0F172A"/>
                 </a:solidFill>
               </a:rPr>
-              <a:t>Caveats</a:t>
-            </a:r>
-          </a:p>
-          <a:p>
-            <a:pPr>
-              <a:spcAft>
-                <a:spcPts val="600"/>
-              </a:spcAft>
-            </a:pPr>
-            <a:r>
-              <a:rPr b="1" sz="1400">
-                <a:solidFill>
-                  <a:srgbClr val="2C7FB8"/>
-                </a:solidFill>
-              </a:rPr>
-              <a:t>finding:  </a:t>
-            </a:r>
-            <a:r>
-              <a:rPr sz="1400">
-                <a:solidFill>
-                  <a:srgbClr val="0F172A"/>
-                </a:solidFill>
-              </a:rPr>
-              <a:t>No elevation-resolved forcing → the recharge–elevation slope (−31.8/1000 m) is an artifact of soil covarying with band; ignore it.</a:t>
-            </a:r>
-          </a:p>
-          <a:p>
-            <a:pPr>
-              <a:spcAft>
-                <a:spcPts val="600"/>
-              </a:spcAft>
-            </a:pPr>
-            <a:r>
-              <a:rPr b="1" sz="1400">
-                <a:solidFill>
-                  <a:srgbClr val="2C7FB8"/>
-                </a:solidFill>
-              </a:rPr>
-              <a:t>finding:  </a:t>
-            </a:r>
-            <a:r>
-              <a:rPr sz="1400">
-                <a:solidFill>
-                  <a:srgbClr val="0F172A"/>
-                </a:solidFill>
-              </a:rPr>
-              <a:t>N=8 with only col_02 as high-Ksat: the entire "recharge happens" conclusion rests on one replicate.</a:t>
-            </a:r>
-          </a:p>
-          <a:p>
-            <a:pPr>
-              <a:spcAft>
-                <a:spcPts val="600"/>
-              </a:spcAft>
-            </a:pPr>
-            <a:r>
-              <a:rPr b="1" sz="1400">
-                <a:solidFill>
-                  <a:srgbClr val="2C7FB8"/>
-                </a:solidFill>
-              </a:rPr>
-              <a:t>finding:  </a:t>
-            </a:r>
-            <a:r>
-              <a:rPr sz="1400">
-                <a:solidFill>
-                  <a:srgbClr val="0F172A"/>
-                </a:solidFill>
-              </a:rPr>
-              <a:t>1-yr, no spin-up: deep states/TWS unequilibrated; negative recharge partly transient.</a:t>
-            </a:r>
-          </a:p>
-          <a:p>
-            <a:pPr>
-              <a:spcAft>
-                <a:spcPts val="600"/>
-              </a:spcAft>
-            </a:pPr>
-            <a:r>
-              <a:rPr b="1" sz="1400">
-                <a:solidFill>
-                  <a:srgbClr val="2C7FB8"/>
-                </a:solidFill>
-              </a:rPr>
-              <a:t>finding:  </a:t>
-            </a:r>
-            <a:r>
-              <a:rPr sz="1400">
-                <a:solidFill>
-                  <a:srgbClr val="0F172A"/>
-                </a:solidFill>
-              </a:rPr>
-              <a:t>No routing → gauge comparisons are order-of-magnitude only; gauges likely drain wetter headwaters.</a:t>
+              <a:t>Ingest gridded soil + spin-up to test whether coarse-soil fraction reconciles recharge and water-table depth.</a:t>
             </a:r>
           </a:p>
         </p:txBody>
@@ -6193,7 +6009,7 @@
                   <a:srgbClr val="0F172A"/>
                 </a:solidFill>
               </a:rPr>
-              <a:t>Key findings</a:t>
+              <a:t>Answer**</a:t>
             </a:r>
           </a:p>
           <a:p>
@@ -6216,7 +6032,7 @@
                   <a:srgbClr val="0F172A"/>
                 </a:solidFill>
               </a:rPr>
-              <a:t>1. Recharge collapses monotonically with clay: 754.7 mm/yr (clay5) → 8.6 mm/yr (clay55), an ~88× drop at fixed precip (1373 mm/yr); r = −0.932.</a:t>
+              <a:t>Increasing topsoil clay from 5% to 55% cuts annual recharge ~88× (754.7→8.6 mm/yr) and flips the system from recharge- to runoff-dominated: recharge fraction drops 0.88→0.10 while runoff fraction rises 0.12→0.90, with the crossover near 45% clay (recharge:runoff ≈0.97).</a:t>
             </a:r>
           </a:p>
           <a:p>
@@ -6239,7 +6055,7 @@
                   <a:srgbClr val="0F172A"/>
                 </a:solidFill>
               </a:rPr>
-              <a:t>2. Recharge:runoff ratio crosses 1.0 near clay45 (0.97), flipping the column from recharge-dominated (clay5 = 7.24) to runoff-dominated (clay55 = 0.12).</a:t>
+              <a:t>Why**</a:t>
             </a:r>
           </a:p>
           <a:p>
@@ -6262,7 +6078,7 @@
                   <a:srgbClr val="0F172A"/>
                 </a:solidFill>
               </a:rPr>
-              <a:t>3. Runoff does NOT rise with clay — it *falls* from 104.3 → 69.9 mm/yr (r = −0.733), counter to the expected infiltration-excess response.</a:t>
+              <a:t>Clay 5→55% -&gt; recharge 754.7→8.6 mm/yr; low Ksat blocks infiltration.</a:t>
             </a:r>
           </a:p>
           <a:p>
@@ -6285,7 +6101,7 @@
                   <a:srgbClr val="0F172A"/>
                 </a:solidFill>
               </a:rPr>
-              <a:t>4. The missing budget term (precip − recharge − runoff) balloons from ~514 mm (clay5) to ~1291 mm (clay55, 94% of precip), implying ET/storage absorbs nearly all rejected recharge.</a:t>
+              <a:t>Clay 5→55% -&gt; runoff fraction 0.12→0.90; rejected water runs off.</a:t>
             </a:r>
           </a:p>
           <a:p>
@@ -6308,7 +6124,7 @@
                   <a:srgbClr val="0F172A"/>
                 </a:solidFill>
               </a:rPr>
-              <a:t>5. Water-table depth deepens only slightly (7.84 → 8.80 m) and TWS seasonal range is nearly flat (~950–1002 mm), so the huge recharge signal is not showing up in equilibrated storage.</a:t>
+              <a:t>Clay_max -&gt; recharge r=−0.932 (forcing held 1373 mm/yr); soil-driven, not climate.</a:t>
             </a:r>
           </a:p>
           <a:p>
@@ -6331,7 +6147,7 @@
                   <a:srgbClr val="0F172A"/>
                 </a:solidFill>
               </a:rPr>
-              <a:t>Water-balance story</a:t>
+              <a:t>Clay 5→55% -&gt; water table 7.84→8.80 m; less deep drainage, deeper WT.</a:t>
             </a:r>
           </a:p>
           <a:p>
@@ -6354,7 +6170,7 @@
                   <a:srgbClr val="0F172A"/>
                 </a:solidFill>
               </a:rPr>
-              <a:t>The reported `recharge_fraction`/`runoff_fraction` sum to 1.0 exactly — they are fractions of (recharge+runoff), **not** of precip, so they hide ET. Reconstructing against the 1373 mm forcing: low-clay columns partition ~55% to recharge, ~8% to runoff, ~37% to ET+storage. High-clay columns partition &lt;1% to recharge, ~5% to runoff, and ~94% to ET+ΔS. Mechanistically, low K_sat clay throttles vertical drainage, so infiltrated water is held in shallow layers where it is re-evaporated rather than either recharging or generating surface runoff. That evaporative shunt explains why runoff paradoxically declines. Closure cannot be verified — no explicit ET, infiltration, or ΔS terms were provided, and the 1291 mm residual is too large to be physical steady-state; some is almost certainly transient storage drawdown from the missing spin-up.</a:t>
+              <a:t>Trust**</a:t>
             </a:r>
           </a:p>
           <a:p>
@@ -6377,7 +6193,7 @@
                   <a:srgbClr val="0F172A"/>
                 </a:solidFill>
               </a:rPr>
-              <a:t>What the validation says</a:t>
+              <a:t>Strong soil-recharge signal (r=−0.932) with precip fixed isolates texture; but no observational validation and Ksat values are null, so the recharge-clay mapping rests on model pedotransfer assumptions.</a:t>
             </a:r>
           </a:p>
           <a:p>
@@ -6400,7 +6216,7 @@
                   <a:srgbClr val="0F172A"/>
                 </a:solidFill>
               </a:rPr>
-              <a:t>Nothing. `targets` is null and `hydrograph_metrics` is empty — there is no observational anchor. Every absolute flux (recharge, runoff, WTD) is unconstrained; only the *relative* clay response is defensible.</a:t>
+              <a:t>Next**</a:t>
             </a:r>
           </a:p>
           <a:p>
@@ -6423,7 +6239,7 @@
                   <a:srgbClr val="0F172A"/>
                 </a:solidFill>
               </a:rPr>
-              <a:t>Caveats</a:t>
+              <a:t>Add water-table/streamflow observations to confirm the ~45% runoff crossover.</a:t>
             </a:r>
           </a:p>
           <a:p>
@@ -6446,76 +6262,7 @@
                   <a:srgbClr val="0F172A"/>
                 </a:solidFill>
               </a:rPr>
-              <a:t>Coarse uniform forcing + single-column physics: no lateral flow, no routing, so "runoff" here is a local generation term, not streamflow — its non-monotonicity may be a physics artifact.</a:t>
-            </a:r>
-          </a:p>
-          <a:p>
-            <a:pPr>
-              <a:spcAft>
-                <a:spcPts val="600"/>
-              </a:spcAft>
-            </a:pPr>
-            <a:r>
-              <a:rPr b="1" sz="1400">
-                <a:solidFill>
-                  <a:srgbClr val="2C7FB8"/>
-                </a:solidFill>
-              </a:rPr>
-              <a:t>finding:  </a:t>
-            </a:r>
-            <a:r>
-              <a:rPr sz="1400">
-                <a:solidFill>
-                  <a:srgbClr val="0F172A"/>
-                </a:solidFill>
-              </a:rPr>
-              <a:t>1-yr, no spin-up: storage/WTD not equilibrated; the growing residual is likely partly transient.</a:t>
-            </a:r>
-          </a:p>
-          <a:p>
-            <a:pPr>
-              <a:spcAft>
-                <a:spcPts val="600"/>
-              </a:spcAft>
-            </a:pPr>
-            <a:r>
-              <a:rPr b="1" sz="1400">
-                <a:solidFill>
-                  <a:srgbClr val="2C7FB8"/>
-                </a:solidFill>
-              </a:rPr>
-              <a:t>finding:  </a:t>
-            </a:r>
-            <a:r>
-              <a:rPr sz="1400">
-                <a:solidFill>
-                  <a:srgbClr val="0F172A"/>
-                </a:solidFill>
-              </a:rPr>
-              <a:t>N=7, no replicates; clay55 is a leverage endpoint driving the ratio&lt;1 crossing and the −0.932 correlation. One anomalous column would shift conclusions.</a:t>
-            </a:r>
-          </a:p>
-          <a:p>
-            <a:pPr>
-              <a:spcAft>
-                <a:spcPts val="600"/>
-              </a:spcAft>
-            </a:pPr>
-            <a:r>
-              <a:rPr b="1" sz="1400">
-                <a:solidFill>
-                  <a:srgbClr val="2C7FB8"/>
-                </a:solidFill>
-              </a:rPr>
-              <a:t>finding:  </a:t>
-            </a:r>
-            <a:r>
-              <a:rPr sz="1400">
-                <a:solidFill>
-                  <a:srgbClr val="0F172A"/>
-                </a:solidFill>
-              </a:rPr>
-              <a:t>K_sat not reported (`ksat_min_ums` null), so the clay→drainage link is inferred</a:t>
+              <a:t>Vary Ksat independently of clay% (currently null) to disentangle texture vs. conductivity control on recharge.</a:t>
             </a:r>
           </a:p>
         </p:txBody>
@@ -14218,7 +13965,7 @@
                   <a:srgbClr val="0F172A"/>
                 </a:solidFill>
               </a:rPr>
-              <a:t>Key findings</a:t>
+              <a:t>Answer**</a:t>
             </a:r>
           </a:p>
           <a:p>
@@ -14241,7 +13988,7 @@
                   <a:srgbClr val="0F172A"/>
                 </a:solidFill>
               </a:rPr>
-              <a:t>1. Forcing is quantized to just **two precip values (793 and 1373 mm/yr)** and is *not* elevation-resolved — so any "elevation gradient" is really a wet/dry forcing switch (recharge–precip r=0.897 &gt; recharge–elevation r=0.593, elevation fit r²=0.35).</a:t>
+              <a:t>In the wet columns (1373 mm/yr precip) recharge dominates partitioning at 81–87% of throughput (~510–650 mm/yr) with only 13–19% runoff, whereas the two dry columns (793 mm/yr) yield essentially zero recharge and route nearly all water to runoff — so partitioning is set by precipitation forcing (r=0.897) and soil clay (r=−0.877), not elevation (weak fit, r²=0.35).</a:t>
             </a:r>
           </a:p>
           <a:p>
@@ -14264,7 +14011,7 @@
                   <a:srgbClr val="0F172A"/>
                 </a:solidFill>
               </a:rPr>
-              <a:t>2. Two regimes emerge: **dry columns (col_01, col_04; 793 mm/yr) yield near-zero recharge** (−0.03, −0.08 mm/yr; recharge fraction ≈0) with drainage entirely as runoff; **wet columns (1373 mm/yr) send 81–87%** of drainage to recharge.</a:t>
+              <a:t>Why**</a:t>
             </a:r>
           </a:p>
           <a:p>
@@ -14287,7 +14034,7 @@
                   <a:srgbClr val="0F172A"/>
                 </a:solidFill>
               </a:rPr>
-              <a:t>3. Within the wet regime (precip held at 1373, N=8) partitioning is **soil-controlled: recharge vs clay_max r=−0.877**, Ksat_min r=+0.512.</a:t>
+              <a:t>Precip step 793→1373 mm/yr -&gt; recharge fraction −0.001→0.81+ : threshold wetness enables drainage.</a:t>
             </a:r>
           </a:p>
           <a:p>
@@ -14310,7 +14057,7 @@
                   <a:srgbClr val="0F172A"/>
                 </a:solidFill>
               </a:rPr>
-              <a:t>4. Clay signature is monotonic: col_06 (clay_max 7.5%) recharge 648 mm/yr → col_03/07/09 (14%) 576 → col_02 (25%) 347 → col_08 (21%) 309.</a:t>
+              <a:t>Clay-max ↑ (col_02/08, 25–31%) -&gt; recharge drops to 310–347 mm/yr : low-Ksat base perches flow.</a:t>
             </a:r>
           </a:p>
           <a:p>
@@ -14333,7 +14080,7 @@
                   <a:srgbClr val="0F172A"/>
                 </a:solidFill>
               </a:rPr>
-              <a:t>5. The dry-regime zero-recharge columns are **confounded** — both are low-precip *and* clay-rich (clay_max 31–32%), so low precip and impedance cannot be separated with these two replicates.</a:t>
+              <a:t>Low-clay/high-Ksat (col_03/06, ≤14%) -&gt; recharge peaks 576–648 mm/yr : open profile drains freely.</a:t>
             </a:r>
           </a:p>
           <a:p>
@@ -14356,7 +14103,7 @@
                   <a:srgbClr val="0F172A"/>
                 </a:solidFill>
               </a:rPr>
-              <a:t>Water-balance story</a:t>
+              <a:t>Elevation +1000 m -&gt; runoff only +18 mm/yr (r²=0.20) : elevation acts mainly via forcing, unresolved here.</a:t>
             </a:r>
           </a:p>
           <a:p>
@@ -14379,7 +14126,7 @@
                   <a:srgbClr val="0F172A"/>
                 </a:solidFill>
               </a:rPr>
-              <a:t>Fractions reported are of drainage (runoff+recharge), not of precip. **Wet regime (1373 mm/yr):** runoff+recharge ≈ 661 mm (col_03), leaving ~700 mm to ET+storage; recharge dominates (576) over runoff (85). Deep, permeable, low-clay profiles (Ksat 9–28 µm/s) let melt percolate. **Dry regime (793 mm/yr):** runoff+recharge ≈ 53 mm, ~740 mm to ET; the clay subsoil (Ksat 3 µm/s) blocks vertical drainage so what little water isn't evaporated leaves as surface/lateral runoff. TWS seasonal ranges are large (467–1043 mm), consistent with strong snow accumulation/melt storage swings — but with 1-yr no-spin-up these storage terms are not equilibrated, so closure residuals cannot be trusted as recharge estimates.</a:t>
+              <a:t>Trust**</a:t>
             </a:r>
           </a:p>
           <a:p>
@@ -14402,7 +14149,7 @@
                   <a:srgbClr val="0F172A"/>
                 </a:solidFill>
               </a:rPr>
-              <a:t>Mechanism:** a low-Ksat clay base creates perched saturation above it; once the cap fills, further input is shed laterally (runoff) rather than draining downward, depressing recharge — exactly the col_02/col_08 (high-clay) vs col_06 (low-clay) contrast.</a:t>
+              <a:t>Modeled water yield 490 vs observed 1427 mm/yr under-predicts ~3× (headwater gauge bias); recharge is an unvalidated residual. Top caveat: precip is quantized to 2 bins, not elevation-downscaled, so the elevation gradient is artificial.</a:t>
             </a:r>
           </a:p>
           <a:p>
@@ -14425,7 +14172,7 @@
                   <a:srgbClr val="0F172A"/>
                 </a:solidFill>
               </a:rPr>
-              <a:t>What the validation says</a:t>
+              <a:t>Next**</a:t>
             </a:r>
           </a:p>
           <a:p>
@@ -14448,7 +14195,7 @@
                   <a:srgbClr val="0F172A"/>
                 </a:solidFill>
               </a:rPr>
-              <a:t>Water table:** model 8.37 m vs Fan 3.11 m vs USGS wells 15.23 m (n=9, not co-located). The column table is a shallow/perched feature; without groundwater coupling+spin-up these offsets are expected and it is **not validated**.</a:t>
+              <a:t>Rerun with elevation-downscaled forcing to separate snow-regime from the precip step.</a:t>
             </a:r>
           </a:p>
           <a:p>
@@ -14471,7 +14218,7 @@
                   <a:srgbClr val="0F172A"/>
                 </a:solidFill>
               </a:rPr>
-              <a:t>Water y</a:t>
+              <a:t>Add gridded soil + groundwater coupling to test the clay-recharge control and deep-WTD offset (8.4 vs 15 m).</a:t>
             </a:r>
           </a:p>
         </p:txBody>

</xml_diff>